<commit_message>
Tighten talk-deck copy (sharper, less staged) + shot-list workflow
</commit_message>
<xml_diff>
--- a/dbms/docs/report/SkyRoute_Presentation.pptx
+++ b/dbms/docs/report/SkyRoute_Presentation.pptx
@@ -168,7 +168,7 @@
     </p:spTree>
     <p:extLst>
       <p:ext uri="{BB962C8B-B14F-4D97-AF65-F5344CB8AC3E}">
-        <p14:creationId xmlns:p14="http://schemas.microsoft.com/office/powerpoint/2010/main" val="3940562224"/>
+        <p14:creationId xmlns:p14="http://schemas.microsoft.com/office/powerpoint/2010/main" val="3476511717"/>
       </p:ext>
     </p:extLst>
   </p:cSld>
@@ -1955,7 +1955,7 @@
                 <a:ea typeface="Segoe UI Semibold" pitchFamily="34" charset="-122"/>
                 <a:cs typeface="Segoe UI Semibold" pitchFamily="34" charset="-120"/>
               </a:rPr>
-              <a:t>4-minute live demo · click to advance · stop anywhere</a:t>
+              <a:t>click to advance · stop anywhere</a:t>
             </a:r>
             <a:endParaRPr lang="en-US" sz="950" dirty="0"/>
           </a:p>
@@ -6976,7 +6976,7 @@
                 <a:ea typeface="Segoe UI" pitchFamily="34" charset="-122"/>
                 <a:cs typeface="Segoe UI" pitchFamily="34" charset="-120"/>
               </a:rPr>
-              <a:t>Relations are declared once as foreign keys — every join a page needs already lives in the database.</a:t>
+              <a:t>Every join already lives in the database.</a:t>
             </a:r>
             <a:endParaRPr lang="en-US" sz="1050" dirty="0"/>
           </a:p>
@@ -9103,7 +9103,7 @@
                 <a:ea typeface="Segoe UI Semibold" pitchFamily="34" charset="-122"/>
                 <a:cs typeface="Segoe UI Semibold" pitchFamily="34" charset="-120"/>
               </a:rPr>
-              <a:t>The rules are created with the tables — then the engine enforces them, no matter who writes.</a:t>
+              <a:t>Rules written once — the engine enforces them, no matter who writes.</a:t>
             </a:r>
             <a:endParaRPr lang="en-US" sz="1250" dirty="0"/>
           </a:p>
@@ -10123,7 +10123,7 @@
                 <a:ea typeface="Segoe UI Semibold" pitchFamily="34" charset="-122"/>
                 <a:cs typeface="Segoe UI Semibold" pitchFamily="34" charset="-120"/>
               </a:rPr>
-              <a:t>Paste the same INSERT twice — the second one is refused. That's the engine, not the app.</a:t>
+              <a:t>One seat. One row. The second INSERT dies — that's the engine, not the app.</a:t>
             </a:r>
             <a:endParaRPr lang="en-US" sz="1050" dirty="0"/>
           </a:p>
@@ -12400,7 +12400,7 @@
                 <a:ea typeface="Segoe UI Semibold" pitchFamily="34" charset="-122"/>
                 <a:cs typeface="Segoe UI Semibold" pitchFamily="34" charset="-120"/>
               </a:rPr>
-              <a:t>Create is guarded · read is views · update is typed · delete cascades — every letter enforced twice</a:t>
+              <a:t>Create is guarded · read is views · update is typed · delete cascades</a:t>
             </a:r>
             <a:endParaRPr lang="en-US" sz="1050" dirty="0"/>
           </a:p>
@@ -14748,46 +14748,7 @@
       </p:sp>
       <p:sp>
         <p:nvSpPr>
-          <p:cNvPr id="26" name="Text 16"/>
-          <p:cNvSpPr/>
-          <p:nvPr/>
-        </p:nvSpPr>
-        <p:spPr>
-          <a:xfrm>
-            <a:off x="932688" y="4901184"/>
-            <a:ext cx="7863840" cy="292608"/>
-          </a:xfrm>
-          <a:prstGeom prst="rect">
-            <a:avLst/>
-          </a:prstGeom>
-          <a:noFill/>
-          <a:ln/>
-        </p:spPr>
-        <p:txBody>
-          <a:bodyPr wrap="square" lIns="0" tIns="0" rIns="0" bIns="0" rtlCol="0" anchor="ctr"/>
-          <a:lstStyle/>
-          <a:p>
-            <a:pPr marL="0" indent="0">
-              <a:buNone/>
-            </a:pPr>
-            <a:r>
-              <a:rPr lang="en-US" sz="1250" i="1" dirty="0">
-                <a:solidFill>
-                  <a:srgbClr val="CFE3C8"/>
-                </a:solidFill>
-                <a:latin typeface="Segoe UI Semibold" pitchFamily="34" charset="0"/>
-                <a:ea typeface="Segoe UI Semibold" pitchFamily="34" charset="-122"/>
-                <a:cs typeface="Segoe UI Semibold" pitchFamily="34" charset="-120"/>
-              </a:rPr>
-              <a:t>That was the brief — it still is.</a:t>
-            </a:r>
-            <a:endParaRPr lang="en-US" sz="1250" dirty="0"/>
-          </a:p>
-        </p:txBody>
-      </p:sp>
-      <p:sp>
-        <p:nvSpPr>
-          <p:cNvPr id="27" name="Shape 17"/>
+          <p:cNvPr id="26" name="Shape 16"/>
           <p:cNvSpPr/>
           <p:nvPr/>
         </p:nvSpPr>
@@ -14809,7 +14770,7 @@
       </p:sp>
       <p:pic>
         <p:nvPicPr>
-          <p:cNvPr id="28" name="Image 8" descr="C:\Users\dwada\AppData\Local\Temp\opencode\assets\icfai.png"/>
+          <p:cNvPr id="27" name="Image 8" descr="C:\Users\dwada\AppData\Local\Temp\opencode\assets\icfai.png"/>
           <p:cNvPicPr>
             <a:picLocks noChangeAspect="1"/>
           </p:cNvPicPr>
@@ -14833,7 +14794,7 @@
       </p:pic>
       <p:sp>
         <p:nvSpPr>
-          <p:cNvPr id="29" name="Text 18"/>
+          <p:cNvPr id="28" name="Text 17"/>
           <p:cNvSpPr/>
           <p:nvPr/>
         </p:nvSpPr>
@@ -14915,7 +14876,7 @@
       </p:sp>
       <p:sp>
         <p:nvSpPr>
-          <p:cNvPr id="30" name="Text 19"/>
+          <p:cNvPr id="29" name="Text 18"/>
           <p:cNvSpPr/>
           <p:nvPr/>
         </p:nvSpPr>
@@ -14954,7 +14915,7 @@
       </p:sp>
       <p:sp>
         <p:nvSpPr>
-          <p:cNvPr id="31" name="Text 20"/>
+          <p:cNvPr id="30" name="Text 19"/>
           <p:cNvSpPr/>
           <p:nvPr/>
         </p:nvSpPr>
@@ -15918,7 +15879,7 @@
                                 </p:cTn>
                               </p:par>
                               <p:par>
-                                <p:cTn id="79" presetID="10" presetClass="entr" presetSubtype="0" fill="hold" grpId="0" nodeType="withEffect">
+                                <p:cTn id="79" presetID="10" presetClass="entr" presetSubtype="0" fill="hold" nodeType="withEffect">
                                   <p:stCondLst>
                                     <p:cond delay="1200"/>
                                   </p:stCondLst>
@@ -15988,7 +15949,7 @@
                                 </p:cTn>
                               </p:par>
                               <p:par>
-                                <p:cTn id="85" presetID="10" presetClass="entr" presetSubtype="0" fill="hold" nodeType="withEffect">
+                                <p:cTn id="85" presetID="10" presetClass="entr" presetSubtype="0" fill="hold" grpId="0" nodeType="withEffect">
                                   <p:stCondLst>
                                     <p:cond delay="1300"/>
                                   </p:stCondLst>
@@ -16016,41 +15977,6 @@
                                         <p:cTn id="87" dur="450"/>
                                         <p:tgtEl>
                                           <p:spTgt spid="28"/>
-                                        </p:tgtEl>
-                                      </p:cBhvr>
-                                    </p:animEffect>
-                                  </p:childTnLst>
-                                </p:cTn>
-                              </p:par>
-                              <p:par>
-                                <p:cTn id="88" presetID="10" presetClass="entr" presetSubtype="0" fill="hold" grpId="0" nodeType="withEffect">
-                                  <p:stCondLst>
-                                    <p:cond delay="1350"/>
-                                  </p:stCondLst>
-                                  <p:childTnLst>
-                                    <p:set>
-                                      <p:cBhvr>
-                                        <p:cTn id="89" dur="1" fill="hold">
-                                          <p:stCondLst>
-                                            <p:cond delay="0"/>
-                                          </p:stCondLst>
-                                        </p:cTn>
-                                        <p:tgtEl>
-                                          <p:spTgt spid="29"/>
-                                        </p:tgtEl>
-                                        <p:attrNameLst>
-                                          <p:attrName>style.visibility</p:attrName>
-                                        </p:attrNameLst>
-                                      </p:cBhvr>
-                                      <p:to>
-                                        <p:strVal val="visible"/>
-                                      </p:to>
-                                    </p:set>
-                                    <p:animEffect transition="in" filter="fade">
-                                      <p:cBhvr>
-                                        <p:cTn id="90" dur="450"/>
-                                        <p:tgtEl>
-                                          <p:spTgt spid="29"/>
                                         </p:tgtEl>
                                       </p:cBhvr>
                                     </p:animEffect>
@@ -16093,8 +16019,7 @@
       <p:bldP spid="19" grpId="0" animBg="1"/>
       <p:bldP spid="22" grpId="0" animBg="1"/>
       <p:bldP spid="25" grpId="0" animBg="1"/>
-      <p:bldP spid="26" grpId="0" animBg="1"/>
-      <p:bldP spid="29" grpId="0" animBg="1"/>
+      <p:bldP spid="28" grpId="0" animBg="1"/>
     </p:bldLst>
   </p:timing>
 </p:sld>

</xml_diff>

<commit_message>
Closing slide reads THAT'S SKYROUTE (drop the tagline)
</commit_message>
<xml_diff>
--- a/dbms/docs/report/SkyRoute_Presentation.pptx
+++ b/dbms/docs/report/SkyRoute_Presentation.pptx
@@ -168,7 +168,7 @@
     </p:spTree>
     <p:extLst>
       <p:ext uri="{BB962C8B-B14F-4D97-AF65-F5344CB8AC3E}">
-        <p14:creationId xmlns:p14="http://schemas.microsoft.com/office/powerpoint/2010/main" val="3476511717"/>
+        <p14:creationId xmlns:p14="http://schemas.microsoft.com/office/powerpoint/2010/main" val="3563627102"/>
       </p:ext>
     </p:extLst>
   </p:cSld>
@@ -749,7 +749,7 @@
           <a:p>
             <a:r>
               <a:rPr lang="en-US" dirty="0"/>
-              <a:t>Close: the rules live in the database now — six boxes, all shown live. Thank you — questions.</a:t>
+              <a:t>Close: THATS SKYROUTE — six boxes, all shown live. Thank you — questions.</a:t>
             </a:r>
           </a:p>
         </p:txBody>
@@ -14022,7 +14022,7 @@
                 <a:ea typeface="Segoe UI Black" pitchFamily="34" charset="-122"/>
                 <a:cs typeface="Segoe UI Black" pitchFamily="34" charset="-120"/>
               </a:rPr>
-              <a:t>THE RULES LIVE</a:t>
+              <a:t>THAT'S</a:t>
             </a:r>
             <a:endParaRPr lang="en-US" sz="5400" dirty="0"/>
           </a:p>
@@ -14042,27 +14042,7 @@
                 <a:ea typeface="Segoe UI Black" pitchFamily="34" charset="-122"/>
                 <a:cs typeface="Segoe UI Black" pitchFamily="34" charset="-120"/>
               </a:rPr>
-              <a:t>IN THE DATABASE</a:t>
-            </a:r>
-            <a:endParaRPr lang="en-US" sz="5400" dirty="0"/>
-          </a:p>
-          <a:p>
-            <a:pPr marL="0" indent="0">
-              <a:lnSpc>
-                <a:spcPct val="100000"/>
-              </a:lnSpc>
-              <a:buNone/>
-            </a:pPr>
-            <a:r>
-              <a:rPr lang="en-US" sz="5400" kern="0" spc="-60" dirty="0">
-                <a:solidFill>
-                  <a:srgbClr val="FFFFFF"/>
-                </a:solidFill>
-                <a:latin typeface="Segoe UI Black" pitchFamily="34" charset="0"/>
-                <a:ea typeface="Segoe UI Black" pitchFamily="34" charset="-122"/>
-                <a:cs typeface="Segoe UI Black" pitchFamily="34" charset="-120"/>
-              </a:rPr>
-              <a:t>NOW</a:t>
+              <a:t>SKYROUTE</a:t>
             </a:r>
             <a:r>
               <a:rPr lang="en-US" sz="5400" kern="0" spc="-60" dirty="0">

</xml_diff>